<commit_message>
chore: update breadberry_pitch.pptx with latest presentation changes
</commit_message>
<xml_diff>
--- a/output/breadberry/breadberry_pitch.pptx
+++ b/output/breadberry/breadberry_pitch.pptx
@@ -108,6 +108,11 @@
       </a:defRPr>
     </a:lvl9pPr>
   </p:defaultTextStyle>
+  <p:extLst>
+    <p:ext uri="{EFAFB233-063F-42B5-8137-9DF3F51BA10A}">
+      <p15:sldGuideLst xmlns:p15="http://schemas.microsoft.com/office/powerpoint/2012/main"/>
+    </p:ext>
+  </p:extLst>
 </p:presentation>
 </file>
 
@@ -5746,52 +5751,82 @@
           <a:lstStyle/>
           <a:p>
             <a:r>
-              <a:rPr lang="en-US" sz="2100" b="1">
+              <a:rPr lang="en-US" sz="2100" b="1" dirty="0" err="1">
                 <a:solidFill>
                   <a:srgbClr val="182D35"/>
                 </a:solidFill>
                 <a:latin typeface="Yu Gothic"/>
                 <a:ea typeface="Yu Gothic"/>
               </a:rPr>
-              <a:t>手取り足取り教える体験を目指して、</a:t>
+              <a:t>手取り足取り教える体験を目指して</a:t>
             </a:r>
-          </a:p>
-        </p:txBody>
-      </p:sp>
-      <p:sp>
-        <p:nvSpPr>
-          <p:cNvPr id="100119" name="TextBox 87"/>
-          <p:cNvSpPr txBox="1"/>
-          <p:nvPr/>
-        </p:nvSpPr>
-        <p:spPr>
-          <a:xfrm>
-            <a:off x="2730500" y="5740400"/>
-            <a:ext cx="8445500" cy="355600"/>
-          </a:xfrm>
-          <a:prstGeom prst="rect">
-            <a:avLst/>
-          </a:prstGeom>
-          <a:noFill/>
-          <a:ln>
-            <a:noFill/>
-          </a:ln>
-        </p:spPr>
-        <p:txBody>
-          <a:bodyPr lIns="0" tIns="0" rIns="0" bIns="0" anchor="ctr">
-            <a:noAutofit/>
-          </a:bodyPr>
-          <a:lstStyle/>
-          <a:p>
             <a:r>
-              <a:rPr lang="en-US" sz="2100" b="1">
+              <a:rPr lang="en-US" sz="2100" b="1" dirty="0">
                 <a:solidFill>
                   <a:srgbClr val="182D35"/>
                 </a:solidFill>
                 <a:latin typeface="Yu Gothic"/>
                 <a:ea typeface="Yu Gothic"/>
               </a:rPr>
-              <a:t>部品・結線のCGモデル化にチャレンジ。</a:t>
+              <a:t>、</a:t>
+            </a:r>
+          </a:p>
+        </p:txBody>
+      </p:sp>
+      <p:sp>
+        <p:nvSpPr>
+          <p:cNvPr id="100119" name="TextBox 87"/>
+          <p:cNvSpPr txBox="1"/>
+          <p:nvPr/>
+        </p:nvSpPr>
+        <p:spPr>
+          <a:xfrm>
+            <a:off x="2730500" y="5740400"/>
+            <a:ext cx="8445500" cy="355600"/>
+          </a:xfrm>
+          <a:prstGeom prst="rect">
+            <a:avLst/>
+          </a:prstGeom>
+          <a:noFill/>
+          <a:ln>
+            <a:noFill/>
+          </a:ln>
+        </p:spPr>
+        <p:txBody>
+          <a:bodyPr lIns="0" tIns="0" rIns="0" bIns="0" anchor="ctr">
+            <a:noAutofit/>
+          </a:bodyPr>
+          <a:lstStyle/>
+          <a:p>
+            <a:r>
+              <a:rPr lang="en-US" sz="2100" b="1" dirty="0" err="1">
+                <a:solidFill>
+                  <a:srgbClr val="182D35"/>
+                </a:solidFill>
+                <a:latin typeface="Yu Gothic"/>
+                <a:ea typeface="Yu Gothic"/>
+              </a:rPr>
+              <a:t>部品・結線のCGモデル化にチャレンジ</a:t>
+            </a:r>
+            <a:r>
+              <a:rPr lang="ja-JP" altLang="en-US" sz="2100" b="1" dirty="0">
+                <a:solidFill>
+                  <a:srgbClr val="182D35"/>
+                </a:solidFill>
+                <a:latin typeface="Yu Gothic"/>
+                <a:ea typeface="Yu Gothic"/>
+              </a:rPr>
+              <a:t>するようにプロンプトを投げました</a:t>
+            </a:r>
+            <a:r>
+              <a:rPr lang="en-US" sz="2100" b="1" dirty="0">
+                <a:solidFill>
+                  <a:srgbClr val="182D35"/>
+                </a:solidFill>
+                <a:latin typeface="Yu Gothic"/>
+                <a:ea typeface="Yu Gothic"/>
+              </a:rPr>
+              <a:t>。</a:t>
             </a:r>
           </a:p>
         </p:txBody>

</xml_diff>

<commit_message>
chore: update breadberry_pitch.pptx with new content
</commit_message>
<xml_diff>
--- a/output/breadberry/breadberry_pitch.pptx
+++ b/output/breadberry/breadberry_pitch.pptx
@@ -5806,7 +5806,7 @@
                 <a:latin typeface="Yu Gothic"/>
                 <a:ea typeface="Yu Gothic"/>
               </a:rPr>
-              <a:t>部品・結線のCGモデル化にチャレンジ</a:t>
+              <a:t>部品</a:t>
             </a:r>
             <a:r>
               <a:rPr lang="ja-JP" altLang="en-US" sz="2100" b="1" dirty="0">
@@ -5816,7 +5816,26 @@
                 <a:latin typeface="Yu Gothic"/>
                 <a:ea typeface="Yu Gothic"/>
               </a:rPr>
-              <a:t>するようにプロンプトを投げました</a:t>
+              <a:t>の配置や結線がわかりやすくなるように</a:t>
+            </a:r>
+            <a:endParaRPr lang="en-US" altLang="ja-JP" sz="2100" b="1" dirty="0">
+              <a:solidFill>
+                <a:srgbClr val="182D35"/>
+              </a:solidFill>
+              <a:latin typeface="Yu Gothic"/>
+              <a:ea typeface="Yu Gothic"/>
+            </a:endParaRPr>
+          </a:p>
+          <a:p>
+            <a:r>
+              <a:rPr lang="ja-JP" altLang="en-US" sz="2100" b="1" dirty="0">
+                <a:solidFill>
+                  <a:srgbClr val="182D35"/>
+                </a:solidFill>
+                <a:latin typeface="Yu Gothic"/>
+                <a:ea typeface="Yu Gothic"/>
+              </a:rPr>
+              <a:t>プロンプトを投げました</a:t>
             </a:r>
             <a:r>
               <a:rPr lang="en-US" sz="2100" b="1" dirty="0">
@@ -5894,7 +5913,7 @@
                 <a:latin typeface="Yu Gothic"/>
                 <a:ea typeface="Yu Gothic"/>
               </a:rPr>
-              <a:t> / Next.js / Gemini API / GMI Cloud / Tailwind CSS</a:t>
+              <a:t> / Next.js / Gemini API (Gemini 3.8-flash)/ GMI Cloud(meta-llama/Llama-3.3-70B-Instruct) / Tailwind CSS</a:t>
             </a:r>
           </a:p>
         </p:txBody>

</xml_diff>